<commit_message>
Korrekturen in LDR Wokwi Beispiel 3
</commit_message>
<xml_diff>
--- a/2_Sensorik/2.4_LDR_Wokwi/2.4_LDR_Wokwi.pptx
+++ b/2_Sensorik/2.4_LDR_Wokwi/2.4_LDR_Wokwi.pptx
@@ -289,7 +289,7 @@
           <a:p>
             <a:fld id="{028B6593-098D-4382-9647-35487FA190B4}" type="datetimeFigureOut">
               <a:rPr lang="de-DE" smtClean="0"/>
-              <a:t>13.04.2026</a:t>
+              <a:t>14.04.2026</a:t>
             </a:fld>
             <a:endParaRPr lang="de-DE"/>
           </a:p>
@@ -11911,30 +11911,6 @@
           </a:prstGeom>
         </p:spPr>
       </p:pic>
-      <p:pic>
-        <p:nvPicPr>
-          <p:cNvPr id="3" name="Grafik 2"/>
-          <p:cNvPicPr>
-            <a:picLocks noChangeAspect="1"/>
-          </p:cNvPicPr>
-          <p:nvPr/>
-        </p:nvPicPr>
-        <p:blipFill>
-          <a:blip r:embed="rId4"/>
-          <a:stretch>
-            <a:fillRect/>
-          </a:stretch>
-        </p:blipFill>
-        <p:spPr>
-          <a:xfrm>
-            <a:off x="717550" y="2443353"/>
-            <a:ext cx="3511550" cy="3213293"/>
-          </a:xfrm>
-          <a:prstGeom prst="rect">
-            <a:avLst/>
-          </a:prstGeom>
-        </p:spPr>
-      </p:pic>
       <p:sp>
         <p:nvSpPr>
           <p:cNvPr id="7" name="Textfeld 6">
@@ -12023,6 +11999,29 @@
           </a:p>
         </p:txBody>
       </p:sp>
+      <p:pic>
+        <p:nvPicPr>
+          <p:cNvPr id="5" name="Grafik 4"/>
+          <p:cNvPicPr>
+            <a:picLocks noChangeAspect="1"/>
+          </p:cNvPicPr>
+          <p:nvPr/>
+        </p:nvPicPr>
+        <p:blipFill rotWithShape="1">
+          <a:blip r:embed="rId4"/>
+          <a:srcRect t="134"/>
+          <a:stretch/>
+        </p:blipFill>
+        <p:spPr>
+          <a:xfrm>
+            <a:off x="717550" y="2524102"/>
+            <a:ext cx="3404507" cy="3132544"/>
+          </a:xfrm>
+          <a:prstGeom prst="rect">
+            <a:avLst/>
+          </a:prstGeom>
+        </p:spPr>
+      </p:pic>
     </p:spTree>
     <p:extLst>
       <p:ext uri="{BB962C8B-B14F-4D97-AF65-F5344CB8AC3E}">
@@ -12209,9 +12208,97 @@
           </a:prstGeom>
         </p:spPr>
       </p:pic>
+      <p:sp>
+        <p:nvSpPr>
+          <p:cNvPr id="7" name="Textfeld 6">
+            <a:extLst>
+              <a:ext uri="{FF2B5EF4-FFF2-40B4-BE49-F238E27FC236}">
+                <a16:creationId xmlns:a16="http://schemas.microsoft.com/office/drawing/2014/main" id="{24B210A7-F815-4E40-A529-0034632E570D}"/>
+              </a:ext>
+            </a:extLst>
+          </p:cNvPr>
+          <p:cNvSpPr txBox="1"/>
+          <p:nvPr/>
+        </p:nvSpPr>
+        <p:spPr>
+          <a:xfrm>
+            <a:off x="4229100" y="5973830"/>
+            <a:ext cx="2758305" cy="215444"/>
+          </a:xfrm>
+          <a:prstGeom prst="rect">
+            <a:avLst/>
+          </a:prstGeom>
+          <a:noFill/>
+        </p:spPr>
+        <p:txBody>
+          <a:bodyPr wrap="square" rtlCol="0">
+            <a:spAutoFit/>
+          </a:bodyPr>
+          <a:lstStyle/>
+          <a:p>
+            <a:r>
+              <a:rPr lang="de-DE" sz="800" dirty="0"/>
+              <a:t>Quelle</a:t>
+            </a:r>
+            <a:r>
+              <a:rPr lang="de-DE" sz="800"/>
+              <a:t>: </a:t>
+            </a:r>
+            <a:r>
+              <a:rPr lang="de-DE" sz="800" smtClean="0"/>
+              <a:t>intern</a:t>
+            </a:r>
+            <a:endParaRPr lang="de-DE" sz="800" dirty="0"/>
+          </a:p>
+        </p:txBody>
+      </p:sp>
+      <p:sp>
+        <p:nvSpPr>
+          <p:cNvPr id="9" name="Textfeld 8">
+            <a:extLst>
+              <a:ext uri="{FF2B5EF4-FFF2-40B4-BE49-F238E27FC236}">
+                <a16:creationId xmlns:a16="http://schemas.microsoft.com/office/drawing/2014/main" id="{24B210A7-F815-4E40-A529-0034632E570D}"/>
+              </a:ext>
+            </a:extLst>
+          </p:cNvPr>
+          <p:cNvSpPr txBox="1"/>
+          <p:nvPr/>
+        </p:nvSpPr>
+        <p:spPr>
+          <a:xfrm>
+            <a:off x="717550" y="5646648"/>
+            <a:ext cx="2758305" cy="215444"/>
+          </a:xfrm>
+          <a:prstGeom prst="rect">
+            <a:avLst/>
+          </a:prstGeom>
+          <a:noFill/>
+        </p:spPr>
+        <p:txBody>
+          <a:bodyPr wrap="square" rtlCol="0">
+            <a:spAutoFit/>
+          </a:bodyPr>
+          <a:lstStyle/>
+          <a:p>
+            <a:r>
+              <a:rPr lang="de-DE" sz="800" dirty="0"/>
+              <a:t>Quelle</a:t>
+            </a:r>
+            <a:r>
+              <a:rPr lang="de-DE" sz="800"/>
+              <a:t>: </a:t>
+            </a:r>
+            <a:r>
+              <a:rPr lang="de-DE" sz="800" smtClean="0"/>
+              <a:t>intern</a:t>
+            </a:r>
+            <a:endParaRPr lang="de-DE" sz="800" dirty="0"/>
+          </a:p>
+        </p:txBody>
+      </p:sp>
       <p:pic>
         <p:nvPicPr>
-          <p:cNvPr id="3" name="Grafik 2"/>
+          <p:cNvPr id="5" name="Grafik 4"/>
           <p:cNvPicPr>
             <a:picLocks noChangeAspect="1"/>
           </p:cNvPicPr>
@@ -12225,102 +12312,14 @@
         </p:blipFill>
         <p:spPr>
           <a:xfrm>
-            <a:off x="717550" y="2454715"/>
-            <a:ext cx="3498850" cy="3191933"/>
+            <a:off x="717550" y="2496457"/>
+            <a:ext cx="3431557" cy="3150191"/>
           </a:xfrm>
           <a:prstGeom prst="rect">
             <a:avLst/>
           </a:prstGeom>
         </p:spPr>
       </p:pic>
-      <p:sp>
-        <p:nvSpPr>
-          <p:cNvPr id="7" name="Textfeld 6">
-            <a:extLst>
-              <a:ext uri="{FF2B5EF4-FFF2-40B4-BE49-F238E27FC236}">
-                <a16:creationId xmlns:a16="http://schemas.microsoft.com/office/drawing/2014/main" id="{24B210A7-F815-4E40-A529-0034632E570D}"/>
-              </a:ext>
-            </a:extLst>
-          </p:cNvPr>
-          <p:cNvSpPr txBox="1"/>
-          <p:nvPr/>
-        </p:nvSpPr>
-        <p:spPr>
-          <a:xfrm>
-            <a:off x="4229100" y="5973830"/>
-            <a:ext cx="2758305" cy="215444"/>
-          </a:xfrm>
-          <a:prstGeom prst="rect">
-            <a:avLst/>
-          </a:prstGeom>
-          <a:noFill/>
-        </p:spPr>
-        <p:txBody>
-          <a:bodyPr wrap="square" rtlCol="0">
-            <a:spAutoFit/>
-          </a:bodyPr>
-          <a:lstStyle/>
-          <a:p>
-            <a:r>
-              <a:rPr lang="de-DE" sz="800" dirty="0"/>
-              <a:t>Quelle</a:t>
-            </a:r>
-            <a:r>
-              <a:rPr lang="de-DE" sz="800"/>
-              <a:t>: </a:t>
-            </a:r>
-            <a:r>
-              <a:rPr lang="de-DE" sz="800" smtClean="0"/>
-              <a:t>intern</a:t>
-            </a:r>
-            <a:endParaRPr lang="de-DE" sz="800" dirty="0"/>
-          </a:p>
-        </p:txBody>
-      </p:sp>
-      <p:sp>
-        <p:nvSpPr>
-          <p:cNvPr id="9" name="Textfeld 8">
-            <a:extLst>
-              <a:ext uri="{FF2B5EF4-FFF2-40B4-BE49-F238E27FC236}">
-                <a16:creationId xmlns:a16="http://schemas.microsoft.com/office/drawing/2014/main" id="{24B210A7-F815-4E40-A529-0034632E570D}"/>
-              </a:ext>
-            </a:extLst>
-          </p:cNvPr>
-          <p:cNvSpPr txBox="1"/>
-          <p:nvPr/>
-        </p:nvSpPr>
-        <p:spPr>
-          <a:xfrm>
-            <a:off x="717550" y="5646648"/>
-            <a:ext cx="2758305" cy="215444"/>
-          </a:xfrm>
-          <a:prstGeom prst="rect">
-            <a:avLst/>
-          </a:prstGeom>
-          <a:noFill/>
-        </p:spPr>
-        <p:txBody>
-          <a:bodyPr wrap="square" rtlCol="0">
-            <a:spAutoFit/>
-          </a:bodyPr>
-          <a:lstStyle/>
-          <a:p>
-            <a:r>
-              <a:rPr lang="de-DE" sz="800" dirty="0"/>
-              <a:t>Quelle</a:t>
-            </a:r>
-            <a:r>
-              <a:rPr lang="de-DE" sz="800"/>
-              <a:t>: </a:t>
-            </a:r>
-            <a:r>
-              <a:rPr lang="de-DE" sz="800" smtClean="0"/>
-              <a:t>intern</a:t>
-            </a:r>
-            <a:endParaRPr lang="de-DE" sz="800" dirty="0"/>
-          </a:p>
-        </p:txBody>
-      </p:sp>
     </p:spTree>
     <p:extLst>
       <p:ext uri="{BB962C8B-B14F-4D97-AF65-F5344CB8AC3E}">
@@ -12665,7 +12664,6 @@
               <a:rPr lang="de-DE" b="1" smtClean="0"/>
               <a:t>2.5_Messwerte_speichern</a:t>
             </a:r>
-            <a:endParaRPr lang="de-DE" b="1" smtClean="0"/>
           </a:p>
         </p:txBody>
       </p:sp>
@@ -18572,6 +18570,21 @@
 </file>
 
 <file path=customXml/item1.xml><?xml version="1.0" encoding="utf-8"?>
+<?mso-contentType ?>
+<FormTemplates xmlns="http://schemas.microsoft.com/sharepoint/v3/contenttype/forms">
+  <Display>DocumentLibraryForm</Display>
+  <Edit>DocumentLibraryForm</Edit>
+  <New>DocumentLibraryForm</New>
+</FormTemplates>
+</file>
+
+<file path=customXml/item2.xml><?xml version="1.0" encoding="utf-8"?>
+<p:properties xmlns:p="http://schemas.microsoft.com/office/2006/metadata/properties" xmlns:xsi="http://www.w3.org/2001/XMLSchema-instance" xmlns:pc="http://schemas.microsoft.com/office/infopath/2007/PartnerControls">
+  <documentManagement/>
+</p:properties>
+</file>
+
+<file path=customXml/item3.xml><?xml version="1.0" encoding="utf-8"?>
 <ct:contentTypeSchema xmlns:ct="http://schemas.microsoft.com/office/2006/metadata/contentType" xmlns:ma="http://schemas.microsoft.com/office/2006/metadata/properties/metaAttributes" ct:_="" ma:_="" ma:contentTypeName="Dokument" ma:contentTypeID="0x0101005DA79B272C4D3C4887957B2C2A69604C" ma:contentTypeVersion="2" ma:contentTypeDescription="Ein neues Dokument erstellen." ma:contentTypeScope="" ma:versionID="a8f11939e8f693b5e60eead0cd42f230">
   <xsd:schema xmlns:xsd="http://www.w3.org/2001/XMLSchema" xmlns:xs="http://www.w3.org/2001/XMLSchema" xmlns:p="http://schemas.microsoft.com/office/2006/metadata/properties" xmlns:ns2="99f41258-1f02-46b6-b230-447d6494c4cb" targetNamespace="http://schemas.microsoft.com/office/2006/metadata/properties" ma:root="true" ma:fieldsID="be05fa88f11a9855f776efdf4611a3d7" ns2:_="">
     <xsd:import namespace="99f41258-1f02-46b6-b230-447d6494c4cb"/>
@@ -18719,22 +18732,31 @@
 </ct:contentTypeSchema>
 </file>
 
-<file path=customXml/item2.xml><?xml version="1.0" encoding="utf-8"?>
-<p:properties xmlns:p="http://schemas.microsoft.com/office/2006/metadata/properties" xmlns:xsi="http://www.w3.org/2001/XMLSchema-instance" xmlns:pc="http://schemas.microsoft.com/office/infopath/2007/PartnerControls">
-  <documentManagement/>
-</p:properties>
+<file path=customXml/itemProps1.xml><?xml version="1.0" encoding="utf-8"?>
+<ds:datastoreItem xmlns:ds="http://schemas.openxmlformats.org/officeDocument/2006/customXml" ds:itemID="{AE15DEB7-8D29-4EC4-857C-8778EFE70922}">
+  <ds:schemaRefs>
+    <ds:schemaRef ds:uri="http://schemas.microsoft.com/sharepoint/v3/contenttype/forms"/>
+  </ds:schemaRefs>
+</ds:datastoreItem>
 </file>
 
-<file path=customXml/item3.xml><?xml version="1.0" encoding="utf-8"?>
-<?mso-contentType ?>
-<FormTemplates xmlns="http://schemas.microsoft.com/sharepoint/v3/contenttype/forms">
-  <Display>DocumentLibraryForm</Display>
-  <Edit>DocumentLibraryForm</Edit>
-  <New>DocumentLibraryForm</New>
-</FormTemplates>
+<file path=customXml/itemProps2.xml><?xml version="1.0" encoding="utf-8"?>
+<ds:datastoreItem xmlns:ds="http://schemas.openxmlformats.org/officeDocument/2006/customXml" ds:itemID="{4D9AF071-B304-4F0F-8459-AC4D742E5C60}">
+  <ds:schemaRefs>
+    <ds:schemaRef ds:uri="http://purl.org/dc/terms/"/>
+    <ds:schemaRef ds:uri="http://purl.org/dc/elements/1.1/"/>
+    <ds:schemaRef ds:uri="http://www.w3.org/XML/1998/namespace"/>
+    <ds:schemaRef ds:uri="http://schemas.microsoft.com/office/2006/documentManagement/types"/>
+    <ds:schemaRef ds:uri="http://schemas.microsoft.com/office/2006/metadata/properties"/>
+    <ds:schemaRef ds:uri="http://purl.org/dc/dcmitype/"/>
+    <ds:schemaRef ds:uri="http://schemas.microsoft.com/office/infopath/2007/PartnerControls"/>
+    <ds:schemaRef ds:uri="http://schemas.openxmlformats.org/package/2006/metadata/core-properties"/>
+    <ds:schemaRef ds:uri="99f41258-1f02-46b6-b230-447d6494c4cb"/>
+  </ds:schemaRefs>
+</ds:datastoreItem>
 </file>
 
-<file path=customXml/itemProps1.xml><?xml version="1.0" encoding="utf-8"?>
+<file path=customXml/itemProps3.xml><?xml version="1.0" encoding="utf-8"?>
 <ds:datastoreItem xmlns:ds="http://schemas.openxmlformats.org/officeDocument/2006/customXml" ds:itemID="{DF333B2F-1563-4DC4-B635-64824C2FC330}">
   <ds:schemaRefs>
     <ds:schemaRef ds:uri="http://schemas.microsoft.com/office/2006/metadata/contentType"/>
@@ -18750,28 +18772,4 @@
     <ds:schemaRef ds:uri="http://schemas.microsoft.com/internal/obd"/>
   </ds:schemaRefs>
 </ds:datastoreItem>
-</file>
-
-<file path=customXml/itemProps2.xml><?xml version="1.0" encoding="utf-8"?>
-<ds:datastoreItem xmlns:ds="http://schemas.openxmlformats.org/officeDocument/2006/customXml" ds:itemID="{4D9AF071-B304-4F0F-8459-AC4D742E5C60}">
-  <ds:schemaRefs>
-    <ds:schemaRef ds:uri="http://www.w3.org/XML/1998/namespace"/>
-    <ds:schemaRef ds:uri="http://schemas.microsoft.com/office/2006/documentManagement/types"/>
-    <ds:schemaRef ds:uri="http://purl.org/dc/terms/"/>
-    <ds:schemaRef ds:uri="http://purl.org/dc/elements/1.1/"/>
-    <ds:schemaRef ds:uri="http://schemas.openxmlformats.org/package/2006/metadata/core-properties"/>
-    <ds:schemaRef ds:uri="99f41258-1f02-46b6-b230-447d6494c4cb"/>
-    <ds:schemaRef ds:uri="http://schemas.microsoft.com/office/2006/metadata/properties"/>
-    <ds:schemaRef ds:uri="http://schemas.microsoft.com/office/infopath/2007/PartnerControls"/>
-    <ds:schemaRef ds:uri="http://purl.org/dc/dcmitype/"/>
-  </ds:schemaRefs>
-</ds:datastoreItem>
-</file>
-
-<file path=customXml/itemProps3.xml><?xml version="1.0" encoding="utf-8"?>
-<ds:datastoreItem xmlns:ds="http://schemas.openxmlformats.org/officeDocument/2006/customXml" ds:itemID="{AE15DEB7-8D29-4EC4-857C-8778EFE70922}">
-  <ds:schemaRefs>
-    <ds:schemaRef ds:uri="http://schemas.microsoft.com/sharepoint/v3/contenttype/forms"/>
-  </ds:schemaRefs>
-</ds:datastoreItem>
 </file>
</xml_diff>